<commit_message>
Incorporate review feedback into Programme Guideline and facilitator pack.
Merge handbook and deadlines into one weekly guideline, add Vietnamese-safe fonts, citation/submission rules, rubric bands, and Presentation Day Plan.

Co-authored-by: Cursor <cursoragent@cursor.com>
</commit_message>
<xml_diff>
--- a/Participants/4_Shared_Toolkit/GBF_Board_Deck_Template.pptx
+++ b/Participants/4_Shared_Toolkit/GBF_Board_Deck_Template.pptx
@@ -3542,6 +3542,7 @@
                 <a:solidFill>
                   <a:srgbClr val="1B2A4A"/>
                 </a:solidFill>
+                <a:latin typeface="Lexend"/>
               </a:defRPr>
             </a:pPr>
             <a:r>
@@ -3554,6 +3555,7 @@
                 <a:solidFill>
                   <a:srgbClr val="007A87"/>
                 </a:solidFill>
+                <a:latin typeface="Nunito"/>
               </a:defRPr>
             </a:pPr>
             <a:r>
@@ -3566,6 +3568,7 @@
                 <a:solidFill>
                   <a:srgbClr val="666666"/>
                 </a:solidFill>
+                <a:latin typeface="Nunito"/>
               </a:defRPr>
             </a:pPr>
             <a:r>
@@ -3619,6 +3622,7 @@
                 <a:solidFill>
                   <a:srgbClr val="1B2A4A"/>
                 </a:solidFill>
+                <a:latin typeface="Lexend"/>
               </a:defRPr>
             </a:pPr>
             <a:r>
@@ -3655,6 +3659,7 @@
                 <a:solidFill>
                   <a:srgbClr val="007A87"/>
                 </a:solidFill>
+                <a:latin typeface="Lexend"/>
               </a:rPr>
               <a:t>Evidence</a:t>
             </a:r>
@@ -3665,6 +3670,7 @@
                 <a:solidFill>
                   <a:srgbClr val="303030"/>
                 </a:solidFill>
+                <a:latin typeface="Nunito"/>
               </a:rPr>
               <a:t>[Lead stat + source, e.g. waitlist 2,400; placement 63% formal]</a:t>
             </a:r>
@@ -3676,6 +3682,7 @@
                 <a:solidFill>
                   <a:srgbClr val="007A87"/>
                 </a:solidFill>
+                <a:latin typeface="Lexend"/>
               </a:rPr>
               <a:t>Insight</a:t>
             </a:r>
@@ -3686,6 +3693,7 @@
                 <a:solidFill>
                   <a:srgbClr val="303030"/>
                 </a:solidFill>
+                <a:latin typeface="Nunito"/>
               </a:rPr>
               <a:t>[The single most important 'so what']</a:t>
             </a:r>
@@ -3697,6 +3705,7 @@
                 <a:solidFill>
                   <a:srgbClr val="007A87"/>
                 </a:solidFill>
+                <a:latin typeface="Lexend"/>
               </a:rPr>
               <a:t>What we recommend / ask</a:t>
             </a:r>
@@ -3707,6 +3716,7 @@
                 <a:solidFill>
                   <a:srgbClr val="303030"/>
                 </a:solidFill>
+                <a:latin typeface="Nunito"/>
               </a:rPr>
               <a:t>[The specific decision you want from the Board]</a:t>
             </a:r>
@@ -3759,6 +3769,7 @@
                 <a:solidFill>
                   <a:srgbClr val="1B2A4A"/>
                 </a:solidFill>
+                <a:latin typeface="Lexend"/>
               </a:defRPr>
             </a:pPr>
             <a:r>
@@ -3795,6 +3806,7 @@
                 <a:solidFill>
                   <a:srgbClr val="007A87"/>
                 </a:solidFill>
+                <a:latin typeface="Lexend"/>
               </a:rPr>
               <a:t>Evidence</a:t>
             </a:r>
@@ -3805,6 +3817,7 @@
                 <a:solidFill>
                   <a:srgbClr val="303030"/>
                 </a:solidFill>
+                <a:latin typeface="Nunito"/>
               </a:rPr>
               <a:t>Waitlist ~2,400 (D-01); income grew 3% while need grew far faster (D-12)</a:t>
             </a:r>
@@ -3816,6 +3829,7 @@
                 <a:solidFill>
                   <a:srgbClr val="007A87"/>
                 </a:solidFill>
+                <a:latin typeface="Lexend"/>
               </a:rPr>
               <a:t>Insight</a:t>
             </a:r>
@@ -3826,6 +3840,7 @@
                 <a:solidFill>
                   <a:srgbClr val="303030"/>
                 </a:solidFill>
+                <a:latin typeface="Nunito"/>
               </a:rPr>
               <a:t>There is moral urgency to grow - but scaling a broken model repeats Dong Nai</a:t>
             </a:r>
@@ -3837,6 +3852,7 @@
                 <a:solidFill>
                   <a:srgbClr val="007A87"/>
                 </a:solidFill>
+                <a:latin typeface="Lexend"/>
               </a:rPr>
               <a:t>What we recommend / ask</a:t>
             </a:r>
@@ -3847,6 +3863,7 @@
                 <a:solidFill>
                   <a:srgbClr val="303030"/>
                 </a:solidFill>
+                <a:latin typeface="Nunito"/>
               </a:rPr>
               <a:t>[Frame the central trade-off]</a:t>
             </a:r>
@@ -3899,6 +3916,7 @@
                 <a:solidFill>
                   <a:srgbClr val="1B2A4A"/>
                 </a:solidFill>
+                <a:latin typeface="Lexend"/>
               </a:defRPr>
             </a:pPr>
             <a:r>
@@ -3935,6 +3953,7 @@
                 <a:solidFill>
                   <a:srgbClr val="007A87"/>
                 </a:solidFill>
+                <a:latin typeface="Lexend"/>
               </a:rPr>
               <a:t>Evidence</a:t>
             </a:r>
@@ -3945,6 +3964,7 @@
                 <a:solidFill>
                   <a:srgbClr val="303030"/>
                 </a:solidFill>
+                <a:latin typeface="Nunito"/>
               </a:rPr>
               <a:t>BN-02 and ST-05; survey barrier data; Dong Nai internship drop-out 38% (D-02)</a:t>
             </a:r>
@@ -3956,6 +3976,7 @@
                 <a:solidFill>
                   <a:srgbClr val="007A87"/>
                 </a:solidFill>
+                <a:latin typeface="Lexend"/>
               </a:rPr>
               <a:t>Insight</a:t>
             </a:r>
@@ -3966,6 +3987,7 @@
                 <a:solidFill>
                   <a:srgbClr val="303030"/>
                 </a:solidFill>
+                <a:latin typeface="Nunito"/>
               </a:rPr>
               <a:t>A modest transport stipend may lift completion more than any new hub</a:t>
             </a:r>
@@ -3977,6 +3999,7 @@
                 <a:solidFill>
                   <a:srgbClr val="007A87"/>
                 </a:solidFill>
+                <a:latin typeface="Lexend"/>
               </a:rPr>
               <a:t>What we recommend / ask</a:t>
             </a:r>
@@ -3987,6 +4010,7 @@
                 <a:solidFill>
                   <a:srgbClr val="303030"/>
                 </a:solidFill>
+                <a:latin typeface="Nunito"/>
               </a:rPr>
               <a:t>[Recommend a transport pilot? Quantify it]</a:t>
             </a:r>
@@ -4039,6 +4063,7 @@
                 <a:solidFill>
                   <a:srgbClr val="1B2A4A"/>
                 </a:solidFill>
+                <a:latin typeface="Lexend"/>
               </a:defRPr>
             </a:pPr>
             <a:r>
@@ -4075,6 +4100,7 @@
                 <a:solidFill>
                   <a:srgbClr val="007A87"/>
                 </a:solidFill>
+                <a:latin typeface="Lexend"/>
               </a:rPr>
               <a:t>Evidence</a:t>
             </a:r>
@@ -4085,6 +4111,7 @@
                 <a:solidFill>
                   <a:srgbClr val="303030"/>
                 </a:solidFill>
+                <a:latin typeface="Nunito"/>
               </a:rPr>
               <a:t>71% broad vs ~63% formal (ST-02); definition footnote in D-01</a:t>
             </a:r>
@@ -4096,6 +4123,7 @@
                 <a:solidFill>
                   <a:srgbClr val="007A87"/>
                 </a:solidFill>
+                <a:latin typeface="Lexend"/>
               </a:rPr>
               <a:t>Insight</a:t>
             </a:r>
@@ -4106,6 +4134,7 @@
                 <a:solidFill>
                   <a:srgbClr val="303030"/>
                 </a:solidFill>
+                <a:latin typeface="Nunito"/>
               </a:rPr>
               <a:t>Honest dual reporting protects the VPBank relationship, not endangers it</a:t>
             </a:r>
@@ -4117,6 +4146,7 @@
                 <a:solidFill>
                   <a:srgbClr val="007A87"/>
                 </a:solidFill>
+                <a:latin typeface="Lexend"/>
               </a:rPr>
               <a:t>What we recommend / ask</a:t>
             </a:r>
@@ -4127,6 +4157,7 @@
                 <a:solidFill>
                   <a:srgbClr val="303030"/>
                 </a:solidFill>
+                <a:latin typeface="Nunito"/>
               </a:rPr>
               <a:t>[Recommend a reporting standard]</a:t>
             </a:r>
@@ -4179,6 +4210,7 @@
                 <a:solidFill>
                   <a:srgbClr val="1B2A4A"/>
                 </a:solidFill>
+                <a:latin typeface="Lexend"/>
               </a:defRPr>
             </a:pPr>
             <a:r>
@@ -4215,6 +4247,7 @@
                 <a:solidFill>
                   <a:srgbClr val="007A87"/>
                 </a:solidFill>
+                <a:latin typeface="Lexend"/>
               </a:rPr>
               <a:t>Evidence</a:t>
             </a:r>
@@ -4225,6 +4258,7 @@
                 <a:solidFill>
                   <a:srgbClr val="303030"/>
                 </a:solidFill>
+                <a:latin typeface="Nunito"/>
               </a:rPr>
               <a:t>Prioritisation matrix; funding scenarios (DB-5)</a:t>
             </a:r>
@@ -4236,6 +4270,7 @@
                 <a:solidFill>
                   <a:srgbClr val="007A87"/>
                 </a:solidFill>
+                <a:latin typeface="Lexend"/>
               </a:rPr>
               <a:t>Insight</a:t>
             </a:r>
@@ -4246,6 +4281,7 @@
                 <a:solidFill>
                   <a:srgbClr val="303030"/>
                 </a:solidFill>
+                <a:latin typeface="Nunito"/>
               </a:rPr>
               <a:t>[The decisive trade-off between the options]</a:t>
             </a:r>
@@ -4257,6 +4293,7 @@
                 <a:solidFill>
                   <a:srgbClr val="007A87"/>
                 </a:solidFill>
+                <a:latin typeface="Lexend"/>
               </a:rPr>
               <a:t>What we recommend / ask</a:t>
             </a:r>
@@ -4267,6 +4304,7 @@
                 <a:solidFill>
                   <a:srgbClr val="303030"/>
                 </a:solidFill>
+                <a:latin typeface="Nunito"/>
               </a:rPr>
               <a:t>[Name your recommended option]</a:t>
             </a:r>
@@ -4319,6 +4357,7 @@
                 <a:solidFill>
                   <a:srgbClr val="1B2A4A"/>
                 </a:solidFill>
+                <a:latin typeface="Lexend"/>
               </a:defRPr>
             </a:pPr>
             <a:r>
@@ -4355,6 +4394,7 @@
                 <a:solidFill>
                   <a:srgbClr val="007A87"/>
                 </a:solidFill>
+                <a:latin typeface="Lexend"/>
               </a:rPr>
               <a:t>Evidence</a:t>
             </a:r>
@@ -4365,6 +4405,7 @@
                 <a:solidFill>
                   <a:srgbClr val="303030"/>
                 </a:solidFill>
+                <a:latin typeface="Nunito"/>
               </a:rPr>
               <a:t>EP-02 and ST-05 on employer quality; D-11 on staff workload</a:t>
             </a:r>
@@ -4376,6 +4417,7 @@
                 <a:solidFill>
                   <a:srgbClr val="007A87"/>
                 </a:solidFill>
+                <a:latin typeface="Lexend"/>
               </a:rPr>
               <a:t>Insight</a:t>
             </a:r>
@@ -4386,6 +4428,7 @@
                 <a:solidFill>
                   <a:srgbClr val="303030"/>
                 </a:solidFill>
+                <a:latin typeface="Nunito"/>
               </a:rPr>
               <a:t>Early, visible wins build Board and donor confidence</a:t>
             </a:r>
@@ -4397,6 +4440,7 @@
                 <a:solidFill>
                   <a:srgbClr val="007A87"/>
                 </a:solidFill>
+                <a:latin typeface="Lexend"/>
               </a:rPr>
               <a:t>What we recommend / ask</a:t>
             </a:r>
@@ -4407,6 +4451,7 @@
                 <a:solidFill>
                   <a:srgbClr val="303030"/>
                 </a:solidFill>
+                <a:latin typeface="Nunito"/>
               </a:rPr>
               <a:t>0-30 days: [ ...]   31-60: [ ...]   61-90: [ ...]</a:t>
             </a:r>
@@ -4459,6 +4504,7 @@
                 <a:solidFill>
                   <a:srgbClr val="1B2A4A"/>
                 </a:solidFill>
+                <a:latin typeface="Lexend"/>
               </a:defRPr>
             </a:pPr>
             <a:r>
@@ -4495,6 +4541,7 @@
                 <a:solidFill>
                   <a:srgbClr val="007A87"/>
                 </a:solidFill>
+                <a:latin typeface="Lexend"/>
               </a:rPr>
               <a:t>Evidence</a:t>
             </a:r>
@@ -4505,6 +4552,7 @@
                 <a:solidFill>
                   <a:srgbClr val="303030"/>
                 </a:solidFill>
+                <a:latin typeface="Nunito"/>
               </a:rPr>
               <a:t>[Recap the one-line recommendation]</a:t>
             </a:r>
@@ -4516,6 +4564,7 @@
                 <a:solidFill>
                   <a:srgbClr val="007A87"/>
                 </a:solidFill>
+                <a:latin typeface="Lexend"/>
               </a:rPr>
               <a:t>Insight</a:t>
             </a:r>
@@ -4526,6 +4575,7 @@
                 <a:solidFill>
                   <a:srgbClr val="303030"/>
                 </a:solidFill>
+                <a:latin typeface="Nunito"/>
               </a:rPr>
               <a:t>[Why now]</a:t>
             </a:r>
@@ -4537,6 +4587,7 @@
                 <a:solidFill>
                   <a:srgbClr val="007A87"/>
                 </a:solidFill>
+                <a:latin typeface="Lexend"/>
               </a:rPr>
               <a:t>What we recommend / ask</a:t>
             </a:r>
@@ -4547,6 +4598,7 @@
                 <a:solidFill>
                   <a:srgbClr val="303030"/>
                 </a:solidFill>
+                <a:latin typeface="Nunito"/>
               </a:rPr>
               <a:t>1) Approve direction  2) Authorise pilot budget  3) Mandate honest M&amp;E</a:t>
             </a:r>

</xml_diff>

<commit_message>
Ready the GBF case pack for rollout with the A↔B evidence loop.
Add Data Estate Brief → Demand Brief → Analysis Plan before R/FM, align Week 3 timing and gated handoff logistics, and rebuild participant, facilitator, and answer-key materials for consistency.

Co-authored-by: Cursor <cursoragent@cursor.com>
</commit_message>
<xml_diff>
--- a/Participants/4_Shared_Toolkit/GBF_Board_Deck_Template.pptx
+++ b/Participants/4_Shared_Toolkit/GBF_Board_Deck_Template.pptx
@@ -3672,7 +3672,7 @@
                 </a:solidFill>
                 <a:latin typeface="Nunito"/>
               </a:rPr>
-              <a:t>[Lead stat + source, e.g. waitlist 2,400; placement 63% formal]</a:t>
+              <a:t>[Lead evidence + source - your finding, not the engagement letter]</a:t>
             </a:r>
           </a:p>
           <a:p/>
@@ -3773,7 +3773,7 @@
               </a:defRPr>
             </a:pPr>
             <a:r>
-              <a:t>Demand has outpaced funding</a:t>
+              <a:t>What is at stake if the Board postpones</a:t>
             </a:r>
           </a:p>
         </p:txBody>
@@ -3819,7 +3819,7 @@
                 </a:solidFill>
                 <a:latin typeface="Nunito"/>
               </a:rPr>
-              <a:t>Waitlist ~2,400 (D-01); income grew 3% while need grew far faster (D-12)</a:t>
+              <a:t>[Waitlist / funding / staff pressure - cite sources]</a:t>
             </a:r>
           </a:p>
           <a:p/>
@@ -3842,7 +3842,7 @@
                 </a:solidFill>
                 <a:latin typeface="Nunito"/>
               </a:rPr>
-              <a:t>There is moral urgency to grow - but scaling a broken model repeats Dong Nai</a:t>
+              <a:t>There is urgency - but urgency is not a blank cheque for any growth path</a:t>
             </a:r>
           </a:p>
           <a:p/>
@@ -3865,7 +3865,7 @@
                 </a:solidFill>
                 <a:latin typeface="Nunito"/>
               </a:rPr>
-              <a:t>[Frame the central trade-off]</a:t>
+              <a:t>[Frame the tension without naming a preferred dilemma]</a:t>
             </a:r>
           </a:p>
           <a:p/>
@@ -3920,7 +3920,7 @@
               </a:defRPr>
             </a:pPr>
             <a:r>
-              <a:t>Young people drop out when transport costs bite</a:t>
+              <a:t>What the evidence forces you to confront</a:t>
             </a:r>
           </a:p>
         </p:txBody>
@@ -3966,7 +3966,7 @@
                 </a:solidFill>
                 <a:latin typeface="Nunito"/>
               </a:rPr>
-              <a:t>BN-02 and ST-05; survey barrier data; Dong Nai internship drop-out 38% (D-02)</a:t>
+              <a:t>[One hard finding with BN-/ST-/FM- cite]</a:t>
             </a:r>
           </a:p>
           <a:p/>
@@ -3989,7 +3989,7 @@
                 </a:solidFill>
                 <a:latin typeface="Nunito"/>
               </a:rPr>
-              <a:t>A modest transport stipend may lift completion more than any new hub</a:t>
+              <a:t>[Why this finding changes the decision]</a:t>
             </a:r>
           </a:p>
           <a:p/>
@@ -4012,7 +4012,7 @@
                 </a:solidFill>
                 <a:latin typeface="Nunito"/>
               </a:rPr>
-              <a:t>[Recommend a transport pilot? Quantify it]</a:t>
+              <a:t>[What a weak team would ignore]</a:t>
             </a:r>
           </a:p>
           <a:p/>
@@ -4067,7 +4067,7 @@
               </a:defRPr>
             </a:pPr>
             <a:r>
-              <a:t>The headline placement rate flatters us</a:t>
+              <a:t>Where definitions change the story</a:t>
             </a:r>
           </a:p>
         </p:txBody>
@@ -4113,7 +4113,7 @@
                 </a:solidFill>
                 <a:latin typeface="Nunito"/>
               </a:rPr>
-              <a:t>71% broad vs ~63% formal (ST-02); definition footnote in D-01</a:t>
+              <a:t>[Measurement / placement definition finding]</a:t>
             </a:r>
           </a:p>
           <a:p/>
@@ -4136,7 +4136,7 @@
                 </a:solidFill>
                 <a:latin typeface="Nunito"/>
               </a:rPr>
-              <a:t>Honest dual reporting protects the VPBank relationship, not endangers it</a:t>
+              <a:t>Honest dual reporting protects the funder relationship, not endangers it</a:t>
             </a:r>
           </a:p>
           <a:p/>
@@ -4159,7 +4159,7 @@
                 </a:solidFill>
                 <a:latin typeface="Nunito"/>
               </a:rPr>
-              <a:t>[Recommend a reporting standard]</a:t>
+              <a:t>[Recommend a reporting standard only if you earned it]</a:t>
             </a:r>
           </a:p>
           <a:p/>

</xml_diff>